<commit_message>
Documentación al día, comprobación del entorno para opencode 2 y retoques de diseño
- README principal con accesos a la web y la wiki, diagramas y estructura
- README de alumnos, presentación, profesor y archivo reescritos
- comprobar_entorno.sh: bibliotecas, opencode 2.x, clave y llamada real al modelo
- Wiki: «Cómo funciona el taller» sustituye a la versión de juego
- Soluciones de EJ 26 y EJ 27; notas del profesor actualizadas (cifradas)
</commit_message>
<xml_diff>
--- a/presentacion/taller-agentes-ia.pptx
+++ b/presentacion/taller-agentes-ia.pptx
@@ -33443,7 +33443,7 @@
                 <a:ea typeface="Consolas" pitchFamily="34" charset="-122"/>
                 <a:cs typeface="Consolas" pitchFamily="34" charset="-120"/>
               </a:rPr>
-              <a:t>cd replicar_paper &amp;&amp; bash verificar.sh --reranker      # ≈ 6 min en CPU · ≈ 1,6 GB de modelos la primera vez</a:t>
+              <a:t>cd replicar_paper &amp;&amp; bash verificar.sh --reranker      # ≈ 6 min en CPU · 1,6 GB la primera vez</a:t>
             </a:r>
             <a:endParaRPr lang="en-US" sz="1300" dirty="0"/>
           </a:p>
@@ -38111,8 +38111,8 @@
         </p:nvSpPr>
         <p:spPr>
           <a:xfrm>
-            <a:off x="4864608" y="2743200"/>
-            <a:ext cx="2468880" cy="1737360"/>
+            <a:off x="4636008" y="2697480"/>
+            <a:ext cx="2926080" cy="1828800"/>
           </a:xfrm>
           <a:prstGeom prst="ellipse">
             <a:avLst/>
@@ -38136,8 +38136,8 @@
         </p:nvSpPr>
         <p:spPr>
           <a:xfrm>
-            <a:off x="4864608" y="2743200"/>
-            <a:ext cx="2468880" cy="1737360"/>
+            <a:off x="4636008" y="2697480"/>
+            <a:ext cx="2926080" cy="1828800"/>
           </a:xfrm>
           <a:prstGeom prst="rect">
             <a:avLst/>
@@ -39546,7 +39546,7 @@
                 <a:ea typeface="Barlow Condensed" pitchFamily="34" charset="-122"/>
                 <a:cs typeface="Barlow Condensed" pitchFamily="34" charset="-120"/>
               </a:rPr>
-              <a:t>Termina cuando el modelo decide</a:t>
+              <a:t>Acaba cuando el modelo quiere</a:t>
             </a:r>
             <a:endParaRPr lang="en-US" sz="1900" dirty="0"/>
           </a:p>

</xml_diff>

<commit_message>
Instalar Python y Node en Windows, macOS y Linux; el agente se instala con @opencode/cli@2.0.19
El paquete npm opencode-ai se quedó en la 1.18: con él el kit no funciona.
</commit_message>
<xml_diff>
--- a/presentacion/taller-agentes-ia.pptx
+++ b/presentacion/taller-agentes-ia.pptx
@@ -35959,7 +35959,7 @@
                 <a:ea typeface="Calibri" pitchFamily="34" charset="-122"/>
                 <a:cs typeface="Calibri" pitchFamily="34" charset="-120"/>
               </a:rPr>
-              <a:t>Node, Python y la clave que os damos en clase. Paso a paso en la wiki: «Primeros pasos»</a:t>
+              <a:t>Python 3.10+, Node 18+ y la clave que os damos en clase. Paso a paso en la wiki: «Instalar Python» y «Primeros pasos»</a:t>
             </a:r>
             <a:endParaRPr lang="en-US" sz="1500" dirty="0"/>
           </a:p>
@@ -36201,7 +36201,7 @@
                 <a:ea typeface="Consolas" pitchFamily="34" charset="-122"/>
                 <a:cs typeface="Consolas" pitchFamily="34" charset="-120"/>
               </a:rPr>
-              <a:t>npm i -g opencode-ai</a:t>
+              <a:t>npm i -g @opencode/cli@2.0.19</a:t>
             </a:r>
             <a:endParaRPr lang="en-US" sz="1200" dirty="0"/>
           </a:p>
@@ -36782,7 +36782,7 @@
                 <a:ea typeface="Barlow Condensed" pitchFamily="34" charset="-122"/>
                 <a:cs typeface="Barlow Condensed" pitchFamily="34" charset="-120"/>
               </a:rPr>
-              <a:t>Trabaja en copias</a:t>
+              <a:t>¿Sin Python o sin Node?</a:t>
             </a:r>
             <a:endParaRPr lang="en-US" sz="1900" dirty="0"/>
           </a:p>
@@ -36821,7 +36821,7 @@
                 <a:ea typeface="Calibri" pitchFamily="34" charset="-122"/>
                 <a:cs typeface="Calibri" pitchFamily="34" charset="-120"/>
               </a:rPr>
-              <a:t>taller.py prepara cada ejercicio en ~/taller-agentes/, fuera del kit.</a:t>
+              <a:t>Wiki «Instalar Python»: Windows (winget), Mac (brew) y Linux (apt). En Windows, py en vez de python3.</a:t>
             </a:r>
             <a:endParaRPr lang="en-US" sz="1250" dirty="0"/>
           </a:p>

</xml_diff>

<commit_message>
Diapositiva 7: texto centrado en el óvalo y tarjetas sin solaparse
</commit_message>
<xml_diff>
--- a/presentacion/taller-agentes-ia.pptx
+++ b/presentacion/taller-agentes-ia.pptx
@@ -38111,7 +38111,7 @@
         </p:nvSpPr>
         <p:spPr>
           <a:xfrm>
-            <a:off x="4636008" y="2697480"/>
+            <a:off x="4636008" y="2331720"/>
             <a:ext cx="2926080" cy="1828800"/>
           </a:xfrm>
           <a:prstGeom prst="ellipse">
@@ -38136,8 +38136,8 @@
         </p:nvSpPr>
         <p:spPr>
           <a:xfrm>
-            <a:off x="4636008" y="2697480"/>
-            <a:ext cx="2926080" cy="1828800"/>
+            <a:off x="4636008" y="2788920"/>
+            <a:ext cx="2926080" cy="457200"/>
           </a:xfrm>
           <a:prstGeom prst="rect">
             <a:avLst/>
@@ -38161,9 +38161,33 @@
                 <a:ea typeface="Barlow Condensed" pitchFamily="34" charset="-122"/>
                 <a:cs typeface="Barlow Condensed" pitchFamily="34" charset="-120"/>
               </a:rPr>
-              <a:t>Modelo (LLM)
-</a:t>
-            </a:r>
+              <a:t>Modelo (LLM)</a:t>
+            </a:r>
+            <a:endParaRPr lang="en-US" sz="2100" dirty="0"/>
+          </a:p>
+        </p:txBody>
+      </p:sp>
+      <p:sp>
+        <p:nvSpPr>
+          <p:cNvPr id="10" name="Text 7"/>
+          <p:cNvSpPr/>
+          <p:nvPr/>
+        </p:nvSpPr>
+        <p:spPr>
+          <a:xfrm>
+            <a:off x="4636008" y="3246120"/>
+            <a:ext cx="2926080" cy="457200"/>
+          </a:xfrm>
+          <a:prstGeom prst="rect">
+            <a:avLst/>
+          </a:prstGeom>
+          <a:noFill/>
+          <a:ln/>
+        </p:spPr>
+        <p:txBody>
+          <a:bodyPr wrap="square" lIns="0" tIns="0" rIns="0" bIns="0" rtlCol="0" anchor="ctr"/>
+          <a:lstStyle/>
+          <a:p>
             <a:pPr algn="ctr" indent="0" marL="0">
               <a:buNone/>
             </a:pPr>
@@ -38184,7 +38208,7 @@
       </p:sp>
       <p:sp>
         <p:nvSpPr>
-          <p:cNvPr id="10" name="Shape 7"/>
+          <p:cNvPr id="11" name="Shape 8"/>
           <p:cNvSpPr/>
           <p:nvPr/>
         </p:nvSpPr>
@@ -38218,7 +38242,7 @@
       </p:sp>
       <p:sp>
         <p:nvSpPr>
-          <p:cNvPr id="11" name="Shape 8"/>
+          <p:cNvPr id="12" name="Shape 9"/>
           <p:cNvSpPr/>
           <p:nvPr/>
         </p:nvSpPr>
@@ -38245,7 +38269,7 @@
       </p:sp>
       <p:pic>
         <p:nvPicPr>
-          <p:cNvPr id="12" name="Image 1" descr="preencoded.png">    </p:cNvPr>
+          <p:cNvPr id="13" name="Image 1" descr="preencoded.png">    </p:cNvPr>
           <p:cNvPicPr>
             <a:picLocks noChangeAspect="1"/>
           </p:cNvPicPr>
@@ -38269,7 +38293,7 @@
       </p:pic>
       <p:sp>
         <p:nvSpPr>
-          <p:cNvPr id="13" name="Text 9"/>
+          <p:cNvPr id="14" name="Text 10"/>
           <p:cNvSpPr/>
           <p:nvPr/>
         </p:nvSpPr>
@@ -38308,7 +38332,7 @@
       </p:sp>
       <p:sp>
         <p:nvSpPr>
-          <p:cNvPr id="14" name="Text 10"/>
+          <p:cNvPr id="15" name="Text 11"/>
           <p:cNvSpPr/>
           <p:nvPr/>
         </p:nvSpPr>
@@ -38347,7 +38371,7 @@
       </p:sp>
       <p:sp>
         <p:nvSpPr>
-          <p:cNvPr id="15" name="Shape 11"/>
+          <p:cNvPr id="16" name="Shape 12"/>
           <p:cNvSpPr/>
           <p:nvPr/>
         </p:nvSpPr>
@@ -38381,7 +38405,7 @@
       </p:sp>
       <p:sp>
         <p:nvSpPr>
-          <p:cNvPr id="16" name="Shape 12"/>
+          <p:cNvPr id="17" name="Shape 13"/>
           <p:cNvSpPr/>
           <p:nvPr/>
         </p:nvSpPr>
@@ -38408,7 +38432,7 @@
       </p:sp>
       <p:pic>
         <p:nvPicPr>
-          <p:cNvPr id="17" name="Image 2" descr="preencoded.png">    </p:cNvPr>
+          <p:cNvPr id="18" name="Image 2" descr="preencoded.png">    </p:cNvPr>
           <p:cNvPicPr>
             <a:picLocks noChangeAspect="1"/>
           </p:cNvPicPr>
@@ -38432,7 +38456,7 @@
       </p:pic>
       <p:sp>
         <p:nvSpPr>
-          <p:cNvPr id="18" name="Text 13"/>
+          <p:cNvPr id="19" name="Text 14"/>
           <p:cNvSpPr/>
           <p:nvPr/>
         </p:nvSpPr>
@@ -38471,7 +38495,7 @@
       </p:sp>
       <p:sp>
         <p:nvSpPr>
-          <p:cNvPr id="19" name="Text 14"/>
+          <p:cNvPr id="20" name="Text 15"/>
           <p:cNvSpPr/>
           <p:nvPr/>
         </p:nvSpPr>
@@ -38510,7 +38534,7 @@
       </p:sp>
       <p:sp>
         <p:nvSpPr>
-          <p:cNvPr id="20" name="Shape 15"/>
+          <p:cNvPr id="21" name="Shape 16"/>
           <p:cNvSpPr/>
           <p:nvPr/>
         </p:nvSpPr>
@@ -38544,7 +38568,7 @@
       </p:sp>
       <p:sp>
         <p:nvSpPr>
-          <p:cNvPr id="21" name="Shape 16"/>
+          <p:cNvPr id="22" name="Shape 17"/>
           <p:cNvSpPr/>
           <p:nvPr/>
         </p:nvSpPr>
@@ -38571,7 +38595,7 @@
       </p:sp>
       <p:pic>
         <p:nvPicPr>
-          <p:cNvPr id="22" name="Image 3" descr="preencoded.png">    </p:cNvPr>
+          <p:cNvPr id="23" name="Image 3" descr="preencoded.png">    </p:cNvPr>
           <p:cNvPicPr>
             <a:picLocks noChangeAspect="1"/>
           </p:cNvPicPr>
@@ -38595,7 +38619,7 @@
       </p:pic>
       <p:sp>
         <p:nvSpPr>
-          <p:cNvPr id="23" name="Text 17"/>
+          <p:cNvPr id="24" name="Text 18"/>
           <p:cNvSpPr/>
           <p:nvPr/>
         </p:nvSpPr>
@@ -38634,7 +38658,7 @@
       </p:sp>
       <p:sp>
         <p:nvSpPr>
-          <p:cNvPr id="24" name="Text 18"/>
+          <p:cNvPr id="25" name="Text 19"/>
           <p:cNvSpPr/>
           <p:nvPr/>
         </p:nvSpPr>
@@ -38673,7 +38697,7 @@
       </p:sp>
       <p:sp>
         <p:nvSpPr>
-          <p:cNvPr id="25" name="Shape 19"/>
+          <p:cNvPr id="26" name="Shape 20"/>
           <p:cNvSpPr/>
           <p:nvPr/>
         </p:nvSpPr>
@@ -38707,7 +38731,7 @@
       </p:sp>
       <p:sp>
         <p:nvSpPr>
-          <p:cNvPr id="26" name="Shape 20"/>
+          <p:cNvPr id="27" name="Shape 21"/>
           <p:cNvSpPr/>
           <p:nvPr/>
         </p:nvSpPr>
@@ -38734,7 +38758,7 @@
       </p:sp>
       <p:pic>
         <p:nvPicPr>
-          <p:cNvPr id="27" name="Image 4" descr="preencoded.png">    </p:cNvPr>
+          <p:cNvPr id="28" name="Image 4" descr="preencoded.png">    </p:cNvPr>
           <p:cNvPicPr>
             <a:picLocks noChangeAspect="1"/>
           </p:cNvPicPr>
@@ -38758,7 +38782,7 @@
       </p:pic>
       <p:sp>
         <p:nvSpPr>
-          <p:cNvPr id="28" name="Text 21"/>
+          <p:cNvPr id="29" name="Text 22"/>
           <p:cNvSpPr/>
           <p:nvPr/>
         </p:nvSpPr>
@@ -38797,7 +38821,7 @@
       </p:sp>
       <p:sp>
         <p:nvSpPr>
-          <p:cNvPr id="29" name="Text 22"/>
+          <p:cNvPr id="30" name="Text 23"/>
           <p:cNvSpPr/>
           <p:nvPr/>
         </p:nvSpPr>
@@ -38836,18 +38860,18 @@
       </p:sp>
       <p:sp>
         <p:nvSpPr>
-          <p:cNvPr id="30" name="Shape 23"/>
-          <p:cNvSpPr/>
-          <p:nvPr/>
-        </p:nvSpPr>
-        <p:spPr>
-          <a:xfrm>
-            <a:off x="4178808" y="4892040"/>
-            <a:ext cx="3840480" cy="914400"/>
+          <p:cNvPr id="31" name="Shape 24"/>
+          <p:cNvSpPr/>
+          <p:nvPr/>
+        </p:nvSpPr>
+        <p:spPr>
+          <a:xfrm>
+            <a:off x="4178808" y="5257800"/>
+            <a:ext cx="3840480" cy="868680"/>
           </a:xfrm>
           <a:prstGeom prst="roundRect">
             <a:avLst>
-              <a:gd name="adj" fmla="val 14000"/>
+              <a:gd name="adj" fmla="val 14737"/>
             </a:avLst>
           </a:prstGeom>
           <a:solidFill>
@@ -38870,13 +38894,13 @@
       </p:sp>
       <p:sp>
         <p:nvSpPr>
-          <p:cNvPr id="31" name="Shape 24"/>
-          <p:cNvSpPr/>
-          <p:nvPr/>
-        </p:nvSpPr>
-        <p:spPr>
-          <a:xfrm>
-            <a:off x="4379976" y="5074920"/>
+          <p:cNvPr id="32" name="Shape 25"/>
+          <p:cNvSpPr/>
+          <p:nvPr/>
+        </p:nvSpPr>
+        <p:spPr>
+          <a:xfrm>
+            <a:off x="4379976" y="5417820"/>
             <a:ext cx="548640" cy="548640"/>
           </a:xfrm>
           <a:prstGeom prst="roundRect">
@@ -38897,7 +38921,7 @@
       </p:sp>
       <p:pic>
         <p:nvPicPr>
-          <p:cNvPr id="32" name="Image 5" descr="preencoded.png">    </p:cNvPr>
+          <p:cNvPr id="33" name="Image 5" descr="preencoded.png">    </p:cNvPr>
           <p:cNvPicPr>
             <a:picLocks noChangeAspect="1"/>
           </p:cNvPicPr>
@@ -38911,7 +38935,7 @@
         </p:blipFill>
         <p:spPr>
           <a:xfrm>
-            <a:off x="4511650" y="5206594"/>
+            <a:off x="4511650" y="5549494"/>
             <a:ext cx="285293" cy="285293"/>
           </a:xfrm>
           <a:prstGeom prst="rect">
@@ -38921,13 +38945,13 @@
       </p:pic>
       <p:sp>
         <p:nvSpPr>
-          <p:cNvPr id="33" name="Text 25"/>
-          <p:cNvSpPr/>
-          <p:nvPr/>
-        </p:nvSpPr>
-        <p:spPr>
-          <a:xfrm>
-            <a:off x="5093208" y="4983480"/>
+          <p:cNvPr id="34" name="Text 26"/>
+          <p:cNvSpPr/>
+          <p:nvPr/>
+        </p:nvSpPr>
+        <p:spPr>
+          <a:xfrm>
+            <a:off x="5093208" y="5349240"/>
             <a:ext cx="2743200" cy="384048"/>
           </a:xfrm>
           <a:prstGeom prst="rect">
@@ -38960,14 +38984,14 @@
       </p:sp>
       <p:sp>
         <p:nvSpPr>
-          <p:cNvPr id="34" name="Text 26"/>
-          <p:cNvSpPr/>
-          <p:nvPr/>
-        </p:nvSpPr>
-        <p:spPr>
-          <a:xfrm>
-            <a:off x="5093208" y="5349240"/>
-            <a:ext cx="2743200" cy="384048"/>
+          <p:cNvPr id="35" name="Text 27"/>
+          <p:cNvSpPr/>
+          <p:nvPr/>
+        </p:nvSpPr>
+        <p:spPr>
+          <a:xfrm>
+            <a:off x="5093208" y="5715000"/>
+            <a:ext cx="2743200" cy="338328"/>
           </a:xfrm>
           <a:prstGeom prst="rect">
             <a:avLst/>

</xml_diff>